<commit_message>
Voeg slide 'Succescriteria van de onboarding' toe (audit checklist)
Nieuwe slide vóór de afsluiting met de 90-dagen audit checklist en
resultaatboodschap, in de huisstijl van het deck. Deck telt nu 18 slides.
</commit_message>
<xml_diff>
--- a/presentatie/VDT_Klantreis_Presentatie.pptx
+++ b/presentatie/VDT_Klantreis_Presentatie.pptx
@@ -22,6 +22,7 @@
     <p:sldId id="270" r:id="rId21"/>
     <p:sldId id="271" r:id="rId22"/>
     <p:sldId id="272" r:id="rId23"/>
+    <p:sldId id="273" r:id="rId24"/>
   </p:sldIdLst>
   <p:sldSz cx="12191695" cy="6858000" type="screen4x3"/>
   <p:notesSz cx="6858000" cy="9144000"/>
@@ -13876,6 +13877,1318 @@
 </file>
 
 <file path=ppt/slides/slide17.xml><?xml version="1.0" encoding="utf-8"?>
+<p:sld xmlns:a="http://schemas.openxmlformats.org/drawingml/2006/main" xmlns:p="http://schemas.openxmlformats.org/presentationml/2006/main" xmlns:r="http://schemas.openxmlformats.org/officeDocument/2006/relationships">
+  <p:cSld>
+    <p:spTree>
+      <p:nvGrpSpPr>
+        <p:cNvPr id="1" name=""/>
+        <p:cNvGrpSpPr/>
+        <p:nvPr/>
+      </p:nvGrpSpPr>
+      <p:grpSpPr/>
+      <p:sp>
+        <p:nvSpPr>
+          <p:cNvPr id="2" name="Rectangle 1"/>
+          <p:cNvSpPr/>
+          <p:nvPr/>
+        </p:nvSpPr>
+        <p:spPr>
+          <a:xfrm>
+            <a:off x="0" y="0"/>
+            <a:ext cx="12191695" cy="6858000"/>
+          </a:xfrm>
+          <a:prstGeom prst="rect">
+            <a:avLst/>
+          </a:prstGeom>
+          <a:solidFill>
+            <a:srgbClr val="FFFFFF"/>
+          </a:solidFill>
+          <a:ln>
+            <a:noFill/>
+          </a:ln>
+          <a:effectLst/>
+        </p:spPr>
+        <p:style>
+          <a:lnRef idx="1">
+            <a:schemeClr val="accent1"/>
+          </a:lnRef>
+          <a:fillRef idx="3">
+            <a:schemeClr val="accent1"/>
+          </a:fillRef>
+          <a:effectRef idx="2">
+            <a:schemeClr val="accent1"/>
+          </a:effectRef>
+          <a:fontRef idx="minor">
+            <a:schemeClr val="lt1"/>
+          </a:fontRef>
+        </p:style>
+        <p:txBody>
+          <a:bodyPr rtlCol="0" anchor="ctr"/>
+          <a:lstStyle/>
+          <a:p>
+            <a:pPr algn="ctr"/>
+          </a:p>
+        </p:txBody>
+      </p:sp>
+      <p:sp>
+        <p:nvSpPr>
+          <p:cNvPr id="3" name="Rectangle 2"/>
+          <p:cNvSpPr/>
+          <p:nvPr/>
+        </p:nvSpPr>
+        <p:spPr>
+          <a:xfrm>
+            <a:off x="0" y="0"/>
+            <a:ext cx="164592" cy="6858000"/>
+          </a:xfrm>
+          <a:prstGeom prst="rect">
+            <a:avLst/>
+          </a:prstGeom>
+          <a:solidFill>
+            <a:srgbClr val="2FA766"/>
+          </a:solidFill>
+          <a:ln>
+            <a:noFill/>
+          </a:ln>
+          <a:effectLst/>
+        </p:spPr>
+        <p:style>
+          <a:lnRef idx="1">
+            <a:schemeClr val="accent1"/>
+          </a:lnRef>
+          <a:fillRef idx="3">
+            <a:schemeClr val="accent1"/>
+          </a:fillRef>
+          <a:effectRef idx="2">
+            <a:schemeClr val="accent1"/>
+          </a:effectRef>
+          <a:fontRef idx="minor">
+            <a:schemeClr val="lt1"/>
+          </a:fontRef>
+        </p:style>
+        <p:txBody>
+          <a:bodyPr rtlCol="0" anchor="ctr"/>
+          <a:lstStyle/>
+          <a:p>
+            <a:pPr algn="ctr"/>
+          </a:p>
+        </p:txBody>
+      </p:sp>
+      <p:sp>
+        <p:nvSpPr>
+          <p:cNvPr id="4" name="Rectangle 3"/>
+          <p:cNvSpPr/>
+          <p:nvPr/>
+        </p:nvSpPr>
+        <p:spPr>
+          <a:xfrm>
+            <a:off x="640080" y="566928"/>
+            <a:ext cx="502920" cy="109728"/>
+          </a:xfrm>
+          <a:prstGeom prst="rect">
+            <a:avLst/>
+          </a:prstGeom>
+          <a:solidFill>
+            <a:srgbClr val="2FA766"/>
+          </a:solidFill>
+          <a:ln>
+            <a:noFill/>
+          </a:ln>
+          <a:effectLst/>
+        </p:spPr>
+        <p:style>
+          <a:lnRef idx="1">
+            <a:schemeClr val="accent1"/>
+          </a:lnRef>
+          <a:fillRef idx="3">
+            <a:schemeClr val="accent1"/>
+          </a:fillRef>
+          <a:effectRef idx="2">
+            <a:schemeClr val="accent1"/>
+          </a:effectRef>
+          <a:fontRef idx="minor">
+            <a:schemeClr val="lt1"/>
+          </a:fontRef>
+        </p:style>
+        <p:txBody>
+          <a:bodyPr rtlCol="0" anchor="ctr"/>
+          <a:lstStyle/>
+          <a:p>
+            <a:pPr algn="ctr"/>
+          </a:p>
+        </p:txBody>
+      </p:sp>
+      <p:sp>
+        <p:nvSpPr>
+          <p:cNvPr id="5" name="TextBox 4"/>
+          <p:cNvSpPr txBox="1"/>
+          <p:nvPr/>
+        </p:nvSpPr>
+        <p:spPr>
+          <a:xfrm>
+            <a:off x="640080" y="713232"/>
+            <a:ext cx="10789920" cy="320040"/>
+          </a:xfrm>
+          <a:prstGeom prst="rect">
+            <a:avLst/>
+          </a:prstGeom>
+          <a:noFill/>
+        </p:spPr>
+        <p:txBody>
+          <a:bodyPr wrap="square" anchor="t" lIns="0" rIns="0" tIns="0" bIns="0">
+            <a:noAutofit/>
+          </a:bodyPr>
+          <a:lstStyle/>
+          <a:p>
+            <a:pPr algn="l">
+              <a:spcBef>
+                <a:spcPts val="0"/>
+              </a:spcBef>
+            </a:pPr>
+            <a:r>
+              <a:rPr sz="1250" b="1">
+                <a:solidFill>
+                  <a:srgbClr val="2FA766"/>
+                </a:solidFill>
+                <a:latin typeface="Inter"/>
+              </a:rPr>
+              <a:t>NA 90 DAGEN</a:t>
+            </a:r>
+          </a:p>
+        </p:txBody>
+      </p:sp>
+      <p:sp>
+        <p:nvSpPr>
+          <p:cNvPr id="6" name="TextBox 5"/>
+          <p:cNvSpPr txBox="1"/>
+          <p:nvPr/>
+        </p:nvSpPr>
+        <p:spPr>
+          <a:xfrm>
+            <a:off x="640080" y="1024128"/>
+            <a:ext cx="10881360" cy="868680"/>
+          </a:xfrm>
+          <a:prstGeom prst="rect">
+            <a:avLst/>
+          </a:prstGeom>
+          <a:noFill/>
+        </p:spPr>
+        <p:txBody>
+          <a:bodyPr wrap="square" anchor="t" lIns="0" rIns="0" tIns="0" bIns="0">
+            <a:noAutofit/>
+          </a:bodyPr>
+          <a:lstStyle/>
+          <a:p>
+            <a:pPr algn="l">
+              <a:lnSpc>
+                <a:spcPct val="100000"/>
+              </a:lnSpc>
+              <a:spcBef>
+                <a:spcPts val="0"/>
+              </a:spcBef>
+            </a:pPr>
+            <a:r>
+              <a:rPr sz="3000" b="1">
+                <a:solidFill>
+                  <a:srgbClr val="142A33"/>
+                </a:solidFill>
+                <a:latin typeface="Inter"/>
+              </a:rPr>
+              <a:t>Succescriteria van de onboarding</a:t>
+            </a:r>
+          </a:p>
+        </p:txBody>
+      </p:sp>
+      <p:sp>
+        <p:nvSpPr>
+          <p:cNvPr id="7" name="TextBox 6"/>
+          <p:cNvSpPr txBox="1"/>
+          <p:nvPr/>
+        </p:nvSpPr>
+        <p:spPr>
+          <a:xfrm>
+            <a:off x="640080" y="6455664"/>
+            <a:ext cx="5486400" cy="274320"/>
+          </a:xfrm>
+          <a:prstGeom prst="rect">
+            <a:avLst/>
+          </a:prstGeom>
+          <a:noFill/>
+        </p:spPr>
+        <p:txBody>
+          <a:bodyPr wrap="square" anchor="t" lIns="0" rIns="0" tIns="0" bIns="0">
+            <a:noAutofit/>
+          </a:bodyPr>
+          <a:lstStyle/>
+          <a:p>
+            <a:pPr algn="l">
+              <a:spcBef>
+                <a:spcPts val="0"/>
+              </a:spcBef>
+            </a:pPr>
+            <a:r>
+              <a:rPr sz="900" b="0">
+                <a:solidFill>
+                  <a:srgbClr val="525C6B"/>
+                </a:solidFill>
+                <a:latin typeface="Inter"/>
+              </a:rPr>
+              <a:t>VDT Klantreis  ·  Van Dossier naar Ondernemerschap</a:t>
+            </a:r>
+          </a:p>
+        </p:txBody>
+      </p:sp>
+      <p:sp>
+        <p:nvSpPr>
+          <p:cNvPr id="8" name="TextBox 7"/>
+          <p:cNvSpPr txBox="1"/>
+          <p:nvPr/>
+        </p:nvSpPr>
+        <p:spPr>
+          <a:xfrm>
+            <a:off x="10424160" y="6455664"/>
+            <a:ext cx="1280160" cy="274320"/>
+          </a:xfrm>
+          <a:prstGeom prst="rect">
+            <a:avLst/>
+          </a:prstGeom>
+          <a:noFill/>
+        </p:spPr>
+        <p:txBody>
+          <a:bodyPr wrap="square" anchor="t" lIns="0" rIns="0" tIns="0" bIns="0">
+            <a:noAutofit/>
+          </a:bodyPr>
+          <a:lstStyle/>
+          <a:p>
+            <a:pPr algn="r">
+              <a:spcBef>
+                <a:spcPts val="0"/>
+              </a:spcBef>
+            </a:pPr>
+            <a:r>
+              <a:rPr sz="900" b="1">
+                <a:solidFill>
+                  <a:srgbClr val="525C6B"/>
+                </a:solidFill>
+                <a:latin typeface="Inter"/>
+              </a:rPr>
+              <a:t>17</a:t>
+            </a:r>
+          </a:p>
+        </p:txBody>
+      </p:sp>
+      <p:sp>
+        <p:nvSpPr>
+          <p:cNvPr id="9" name="TextBox 8"/>
+          <p:cNvSpPr txBox="1"/>
+          <p:nvPr/>
+        </p:nvSpPr>
+        <p:spPr>
+          <a:xfrm>
+            <a:off x="640080" y="1938528"/>
+            <a:ext cx="10789920" cy="457200"/>
+          </a:xfrm>
+          <a:prstGeom prst="rect">
+            <a:avLst/>
+          </a:prstGeom>
+          <a:noFill/>
+        </p:spPr>
+        <p:txBody>
+          <a:bodyPr wrap="square" anchor="t" lIns="0" rIns="0" tIns="0" bIns="0">
+            <a:noAutofit/>
+          </a:bodyPr>
+          <a:lstStyle/>
+          <a:p>
+            <a:pPr algn="l">
+              <a:spcBef>
+                <a:spcPts val="0"/>
+              </a:spcBef>
+            </a:pPr>
+            <a:r>
+              <a:rPr sz="1500" b="0">
+                <a:solidFill>
+                  <a:srgbClr val="1F2937"/>
+                </a:solidFill>
+                <a:latin typeface="Inter"/>
+              </a:rPr>
+              <a:t>De onboarding is geslaagd als de klant:</a:t>
+            </a:r>
+          </a:p>
+        </p:txBody>
+      </p:sp>
+      <p:sp>
+        <p:nvSpPr>
+          <p:cNvPr id="10" name="Rounded Rectangle 9"/>
+          <p:cNvSpPr/>
+          <p:nvPr/>
+        </p:nvSpPr>
+        <p:spPr>
+          <a:xfrm>
+            <a:off x="640080" y="2560320"/>
+            <a:ext cx="10927080" cy="2788920"/>
+          </a:xfrm>
+          <a:prstGeom prst="roundRect">
+            <a:avLst>
+              <a:gd name="adj" fmla="val 4000"/>
+            </a:avLst>
+          </a:prstGeom>
+          <a:solidFill>
+            <a:srgbClr val="FFFFFF"/>
+          </a:solidFill>
+          <a:ln w="12700">
+            <a:solidFill>
+              <a:srgbClr val="E2E7EA"/>
+            </a:solidFill>
+          </a:ln>
+          <a:effectLst/>
+          <a:effectLst>
+            <a:outerShdw blurRad="90000" dist="38100" dir="5400000" rotWithShape="0">
+              <a:srgbClr val="14323B">
+                <a:alpha val="22000"/>
+              </a:srgbClr>
+            </a:outerShdw>
+          </a:effectLst>
+        </p:spPr>
+        <p:style>
+          <a:lnRef idx="1">
+            <a:schemeClr val="accent1"/>
+          </a:lnRef>
+          <a:fillRef idx="3">
+            <a:schemeClr val="accent1"/>
+          </a:fillRef>
+          <a:effectRef idx="2">
+            <a:schemeClr val="accent1"/>
+          </a:effectRef>
+          <a:fontRef idx="minor">
+            <a:schemeClr val="lt1"/>
+          </a:fontRef>
+        </p:style>
+        <p:txBody>
+          <a:bodyPr rtlCol="0" anchor="ctr"/>
+          <a:lstStyle/>
+          <a:p>
+            <a:pPr algn="ctr"/>
+          </a:p>
+        </p:txBody>
+      </p:sp>
+      <p:sp>
+        <p:nvSpPr>
+          <p:cNvPr id="11" name="Rounded Rectangle 10"/>
+          <p:cNvSpPr/>
+          <p:nvPr/>
+        </p:nvSpPr>
+        <p:spPr>
+          <a:xfrm>
+            <a:off x="640080" y="2560320"/>
+            <a:ext cx="10927080" cy="109728"/>
+          </a:xfrm>
+          <a:prstGeom prst="roundRect">
+            <a:avLst>
+              <a:gd name="adj" fmla="val 50000"/>
+            </a:avLst>
+          </a:prstGeom>
+          <a:solidFill>
+            <a:srgbClr val="2FA766"/>
+          </a:solidFill>
+          <a:ln>
+            <a:noFill/>
+          </a:ln>
+          <a:effectLst/>
+        </p:spPr>
+        <p:style>
+          <a:lnRef idx="1">
+            <a:schemeClr val="accent1"/>
+          </a:lnRef>
+          <a:fillRef idx="3">
+            <a:schemeClr val="accent1"/>
+          </a:fillRef>
+          <a:effectRef idx="2">
+            <a:schemeClr val="accent1"/>
+          </a:effectRef>
+          <a:fontRef idx="minor">
+            <a:schemeClr val="lt1"/>
+          </a:fontRef>
+        </p:style>
+        <p:txBody>
+          <a:bodyPr rtlCol="0" anchor="ctr"/>
+          <a:lstStyle/>
+          <a:p>
+            <a:pPr algn="ctr"/>
+          </a:p>
+        </p:txBody>
+      </p:sp>
+      <p:sp>
+        <p:nvSpPr>
+          <p:cNvPr id="12" name="TextBox 11"/>
+          <p:cNvSpPr txBox="1"/>
+          <p:nvPr/>
+        </p:nvSpPr>
+        <p:spPr>
+          <a:xfrm>
+            <a:off x="1051560" y="2852928"/>
+            <a:ext cx="10104120" cy="411480"/>
+          </a:xfrm>
+          <a:prstGeom prst="rect">
+            <a:avLst/>
+          </a:prstGeom>
+          <a:noFill/>
+        </p:spPr>
+        <p:txBody>
+          <a:bodyPr wrap="square" anchor="t" lIns="0" rIns="0" tIns="0" bIns="0">
+            <a:noAutofit/>
+          </a:bodyPr>
+          <a:lstStyle/>
+          <a:p>
+            <a:pPr algn="l">
+              <a:spcBef>
+                <a:spcPts val="0"/>
+              </a:spcBef>
+            </a:pPr>
+            <a:r>
+              <a:rPr sz="1300" b="1">
+                <a:solidFill>
+                  <a:srgbClr val="2FA766"/>
+                </a:solidFill>
+                <a:latin typeface="Inter"/>
+              </a:rPr>
+              <a:t>AUDIT CHECKLIST</a:t>
+            </a:r>
+          </a:p>
+        </p:txBody>
+      </p:sp>
+      <p:sp>
+        <p:nvSpPr>
+          <p:cNvPr id="13" name="Rounded Rectangle 12"/>
+          <p:cNvSpPr/>
+          <p:nvPr/>
+        </p:nvSpPr>
+        <p:spPr>
+          <a:xfrm>
+            <a:off x="1051560" y="3346704"/>
+            <a:ext cx="10104120" cy="420624"/>
+          </a:xfrm>
+          <a:prstGeom prst="roundRect">
+            <a:avLst>
+              <a:gd name="adj" fmla="val 22000"/>
+            </a:avLst>
+          </a:prstGeom>
+          <a:solidFill>
+            <a:srgbClr val="E9F5EE"/>
+          </a:solidFill>
+          <a:ln>
+            <a:noFill/>
+          </a:ln>
+          <a:effectLst/>
+        </p:spPr>
+        <p:style>
+          <a:lnRef idx="1">
+            <a:schemeClr val="accent1"/>
+          </a:lnRef>
+          <a:fillRef idx="3">
+            <a:schemeClr val="accent1"/>
+          </a:fillRef>
+          <a:effectRef idx="2">
+            <a:schemeClr val="accent1"/>
+          </a:effectRef>
+          <a:fontRef idx="minor">
+            <a:schemeClr val="lt1"/>
+          </a:fontRef>
+        </p:style>
+        <p:txBody>
+          <a:bodyPr rtlCol="0" anchor="ctr"/>
+          <a:lstStyle/>
+          <a:p>
+            <a:pPr algn="ctr"/>
+          </a:p>
+        </p:txBody>
+      </p:sp>
+      <p:sp>
+        <p:nvSpPr>
+          <p:cNvPr id="14" name="Rounded Rectangle 13"/>
+          <p:cNvSpPr/>
+          <p:nvPr/>
+        </p:nvSpPr>
+        <p:spPr>
+          <a:xfrm>
+            <a:off x="1143000" y="3383280"/>
+            <a:ext cx="384048" cy="384048"/>
+          </a:xfrm>
+          <a:prstGeom prst="roundRect">
+            <a:avLst>
+              <a:gd name="adj" fmla="val 30000"/>
+            </a:avLst>
+          </a:prstGeom>
+          <a:solidFill>
+            <a:srgbClr val="2FA766"/>
+          </a:solidFill>
+          <a:ln>
+            <a:noFill/>
+          </a:ln>
+          <a:effectLst/>
+          <a:effectLst>
+            <a:outerShdw blurRad="90000" dist="38100" dir="5400000" rotWithShape="0">
+              <a:srgbClr val="14323B">
+                <a:alpha val="22000"/>
+              </a:srgbClr>
+            </a:outerShdw>
+          </a:effectLst>
+        </p:spPr>
+        <p:style>
+          <a:lnRef idx="1">
+            <a:schemeClr val="accent1"/>
+          </a:lnRef>
+          <a:fillRef idx="3">
+            <a:schemeClr val="accent1"/>
+          </a:fillRef>
+          <a:effectRef idx="2">
+            <a:schemeClr val="accent1"/>
+          </a:effectRef>
+          <a:fontRef idx="minor">
+            <a:schemeClr val="lt1"/>
+          </a:fontRef>
+        </p:style>
+        <p:txBody>
+          <a:bodyPr rtlCol="0" anchor="ctr"/>
+          <a:lstStyle/>
+          <a:p>
+            <a:pPr algn="ctr"/>
+          </a:p>
+        </p:txBody>
+      </p:sp>
+      <p:sp>
+        <p:nvSpPr>
+          <p:cNvPr id="15" name="TextBox 14"/>
+          <p:cNvSpPr txBox="1"/>
+          <p:nvPr/>
+        </p:nvSpPr>
+        <p:spPr>
+          <a:xfrm>
+            <a:off x="1143000" y="3383280"/>
+            <a:ext cx="384048" cy="384048"/>
+          </a:xfrm>
+          <a:prstGeom prst="rect">
+            <a:avLst/>
+          </a:prstGeom>
+          <a:noFill/>
+        </p:spPr>
+        <p:txBody>
+          <a:bodyPr wrap="square" anchor="ctr" lIns="0" rIns="0" tIns="0" bIns="0">
+            <a:noAutofit/>
+          </a:bodyPr>
+          <a:lstStyle/>
+          <a:p>
+            <a:pPr algn="ctr">
+              <a:spcBef>
+                <a:spcPts val="0"/>
+              </a:spcBef>
+            </a:pPr>
+            <a:r>
+              <a:rPr sz="1600" b="1">
+                <a:solidFill>
+                  <a:srgbClr val="FFFFFF"/>
+                </a:solidFill>
+                <a:latin typeface="Inter"/>
+              </a:rPr>
+              <a:t>✓</a:t>
+            </a:r>
+          </a:p>
+        </p:txBody>
+      </p:sp>
+      <p:sp>
+        <p:nvSpPr>
+          <p:cNvPr id="16" name="TextBox 15"/>
+          <p:cNvSpPr txBox="1"/>
+          <p:nvPr/>
+        </p:nvSpPr>
+        <p:spPr>
+          <a:xfrm>
+            <a:off x="1737360" y="3346704"/>
+            <a:ext cx="9372600" cy="420624"/>
+          </a:xfrm>
+          <a:prstGeom prst="rect">
+            <a:avLst/>
+          </a:prstGeom>
+          <a:noFill/>
+        </p:spPr>
+        <p:txBody>
+          <a:bodyPr wrap="square" anchor="ctr" lIns="0" rIns="0" tIns="0" bIns="0">
+            <a:noAutofit/>
+          </a:bodyPr>
+          <a:lstStyle/>
+          <a:p>
+            <a:pPr algn="l">
+              <a:spcBef>
+                <a:spcPts val="0"/>
+              </a:spcBef>
+            </a:pPr>
+            <a:r>
+              <a:rPr sz="1450" b="0">
+                <a:solidFill>
+                  <a:srgbClr val="142A33"/>
+                </a:solidFill>
+                <a:latin typeface="Inter"/>
+              </a:rPr>
+              <a:t>Exact weet wie hij of zij moet bellen bij VDT.</a:t>
+            </a:r>
+          </a:p>
+        </p:txBody>
+      </p:sp>
+      <p:sp>
+        <p:nvSpPr>
+          <p:cNvPr id="17" name="Rounded Rectangle 16"/>
+          <p:cNvSpPr/>
+          <p:nvPr/>
+        </p:nvSpPr>
+        <p:spPr>
+          <a:xfrm>
+            <a:off x="1051560" y="3849624"/>
+            <a:ext cx="10104120" cy="420624"/>
+          </a:xfrm>
+          <a:prstGeom prst="roundRect">
+            <a:avLst>
+              <a:gd name="adj" fmla="val 22000"/>
+            </a:avLst>
+          </a:prstGeom>
+          <a:solidFill>
+            <a:srgbClr val="E9F5EE"/>
+          </a:solidFill>
+          <a:ln>
+            <a:noFill/>
+          </a:ln>
+          <a:effectLst/>
+        </p:spPr>
+        <p:style>
+          <a:lnRef idx="1">
+            <a:schemeClr val="accent1"/>
+          </a:lnRef>
+          <a:fillRef idx="3">
+            <a:schemeClr val="accent1"/>
+          </a:fillRef>
+          <a:effectRef idx="2">
+            <a:schemeClr val="accent1"/>
+          </a:effectRef>
+          <a:fontRef idx="minor">
+            <a:schemeClr val="lt1"/>
+          </a:fontRef>
+        </p:style>
+        <p:txBody>
+          <a:bodyPr rtlCol="0" anchor="ctr"/>
+          <a:lstStyle/>
+          <a:p>
+            <a:pPr algn="ctr"/>
+          </a:p>
+        </p:txBody>
+      </p:sp>
+      <p:sp>
+        <p:nvSpPr>
+          <p:cNvPr id="18" name="Rounded Rectangle 17"/>
+          <p:cNvSpPr/>
+          <p:nvPr/>
+        </p:nvSpPr>
+        <p:spPr>
+          <a:xfrm>
+            <a:off x="1143000" y="3886200"/>
+            <a:ext cx="384048" cy="384048"/>
+          </a:xfrm>
+          <a:prstGeom prst="roundRect">
+            <a:avLst>
+              <a:gd name="adj" fmla="val 30000"/>
+            </a:avLst>
+          </a:prstGeom>
+          <a:solidFill>
+            <a:srgbClr val="2FA766"/>
+          </a:solidFill>
+          <a:ln>
+            <a:noFill/>
+          </a:ln>
+          <a:effectLst/>
+          <a:effectLst>
+            <a:outerShdw blurRad="90000" dist="38100" dir="5400000" rotWithShape="0">
+              <a:srgbClr val="14323B">
+                <a:alpha val="22000"/>
+              </a:srgbClr>
+            </a:outerShdw>
+          </a:effectLst>
+        </p:spPr>
+        <p:style>
+          <a:lnRef idx="1">
+            <a:schemeClr val="accent1"/>
+          </a:lnRef>
+          <a:fillRef idx="3">
+            <a:schemeClr val="accent1"/>
+          </a:fillRef>
+          <a:effectRef idx="2">
+            <a:schemeClr val="accent1"/>
+          </a:effectRef>
+          <a:fontRef idx="minor">
+            <a:schemeClr val="lt1"/>
+          </a:fontRef>
+        </p:style>
+        <p:txBody>
+          <a:bodyPr rtlCol="0" anchor="ctr"/>
+          <a:lstStyle/>
+          <a:p>
+            <a:pPr algn="ctr"/>
+          </a:p>
+        </p:txBody>
+      </p:sp>
+      <p:sp>
+        <p:nvSpPr>
+          <p:cNvPr id="19" name="TextBox 18"/>
+          <p:cNvSpPr txBox="1"/>
+          <p:nvPr/>
+        </p:nvSpPr>
+        <p:spPr>
+          <a:xfrm>
+            <a:off x="1143000" y="3886200"/>
+            <a:ext cx="384048" cy="384048"/>
+          </a:xfrm>
+          <a:prstGeom prst="rect">
+            <a:avLst/>
+          </a:prstGeom>
+          <a:noFill/>
+        </p:spPr>
+        <p:txBody>
+          <a:bodyPr wrap="square" anchor="ctr" lIns="0" rIns="0" tIns="0" bIns="0">
+            <a:noAutofit/>
+          </a:bodyPr>
+          <a:lstStyle/>
+          <a:p>
+            <a:pPr algn="ctr">
+              <a:spcBef>
+                <a:spcPts val="0"/>
+              </a:spcBef>
+            </a:pPr>
+            <a:r>
+              <a:rPr sz="1600" b="1">
+                <a:solidFill>
+                  <a:srgbClr val="FFFFFF"/>
+                </a:solidFill>
+                <a:latin typeface="Inter"/>
+              </a:rPr>
+              <a:t>✓</a:t>
+            </a:r>
+          </a:p>
+        </p:txBody>
+      </p:sp>
+      <p:sp>
+        <p:nvSpPr>
+          <p:cNvPr id="20" name="TextBox 19"/>
+          <p:cNvSpPr txBox="1"/>
+          <p:nvPr/>
+        </p:nvSpPr>
+        <p:spPr>
+          <a:xfrm>
+            <a:off x="1737360" y="3849624"/>
+            <a:ext cx="9372600" cy="420624"/>
+          </a:xfrm>
+          <a:prstGeom prst="rect">
+            <a:avLst/>
+          </a:prstGeom>
+          <a:noFill/>
+        </p:spPr>
+        <p:txBody>
+          <a:bodyPr wrap="square" anchor="ctr" lIns="0" rIns="0" tIns="0" bIns="0">
+            <a:noAutofit/>
+          </a:bodyPr>
+          <a:lstStyle/>
+          <a:p>
+            <a:pPr algn="l">
+              <a:spcBef>
+                <a:spcPts val="0"/>
+              </a:spcBef>
+            </a:pPr>
+            <a:r>
+              <a:rPr sz="1450" b="0">
+                <a:solidFill>
+                  <a:srgbClr val="142A33"/>
+                </a:solidFill>
+                <a:latin typeface="Inter"/>
+              </a:rPr>
+              <a:t>Minimaal twee mensen binnen VDT persoonlijk kent.</a:t>
+            </a:r>
+          </a:p>
+        </p:txBody>
+      </p:sp>
+      <p:sp>
+        <p:nvSpPr>
+          <p:cNvPr id="21" name="Rounded Rectangle 20"/>
+          <p:cNvSpPr/>
+          <p:nvPr/>
+        </p:nvSpPr>
+        <p:spPr>
+          <a:xfrm>
+            <a:off x="1051560" y="4352544"/>
+            <a:ext cx="10104120" cy="420624"/>
+          </a:xfrm>
+          <a:prstGeom prst="roundRect">
+            <a:avLst>
+              <a:gd name="adj" fmla="val 22000"/>
+            </a:avLst>
+          </a:prstGeom>
+          <a:solidFill>
+            <a:srgbClr val="E9F5EE"/>
+          </a:solidFill>
+          <a:ln>
+            <a:noFill/>
+          </a:ln>
+          <a:effectLst/>
+        </p:spPr>
+        <p:style>
+          <a:lnRef idx="1">
+            <a:schemeClr val="accent1"/>
+          </a:lnRef>
+          <a:fillRef idx="3">
+            <a:schemeClr val="accent1"/>
+          </a:fillRef>
+          <a:effectRef idx="2">
+            <a:schemeClr val="accent1"/>
+          </a:effectRef>
+          <a:fontRef idx="minor">
+            <a:schemeClr val="lt1"/>
+          </a:fontRef>
+        </p:style>
+        <p:txBody>
+          <a:bodyPr rtlCol="0" anchor="ctr"/>
+          <a:lstStyle/>
+          <a:p>
+            <a:pPr algn="ctr"/>
+          </a:p>
+        </p:txBody>
+      </p:sp>
+      <p:sp>
+        <p:nvSpPr>
+          <p:cNvPr id="22" name="Rounded Rectangle 21"/>
+          <p:cNvSpPr/>
+          <p:nvPr/>
+        </p:nvSpPr>
+        <p:spPr>
+          <a:xfrm>
+            <a:off x="1143000" y="4389120"/>
+            <a:ext cx="384048" cy="384048"/>
+          </a:xfrm>
+          <a:prstGeom prst="roundRect">
+            <a:avLst>
+              <a:gd name="adj" fmla="val 30000"/>
+            </a:avLst>
+          </a:prstGeom>
+          <a:solidFill>
+            <a:srgbClr val="2FA766"/>
+          </a:solidFill>
+          <a:ln>
+            <a:noFill/>
+          </a:ln>
+          <a:effectLst/>
+          <a:effectLst>
+            <a:outerShdw blurRad="90000" dist="38100" dir="5400000" rotWithShape="0">
+              <a:srgbClr val="14323B">
+                <a:alpha val="22000"/>
+              </a:srgbClr>
+            </a:outerShdw>
+          </a:effectLst>
+        </p:spPr>
+        <p:style>
+          <a:lnRef idx="1">
+            <a:schemeClr val="accent1"/>
+          </a:lnRef>
+          <a:fillRef idx="3">
+            <a:schemeClr val="accent1"/>
+          </a:fillRef>
+          <a:effectRef idx="2">
+            <a:schemeClr val="accent1"/>
+          </a:effectRef>
+          <a:fontRef idx="minor">
+            <a:schemeClr val="lt1"/>
+          </a:fontRef>
+        </p:style>
+        <p:txBody>
+          <a:bodyPr rtlCol="0" anchor="ctr"/>
+          <a:lstStyle/>
+          <a:p>
+            <a:pPr algn="ctr"/>
+          </a:p>
+        </p:txBody>
+      </p:sp>
+      <p:sp>
+        <p:nvSpPr>
+          <p:cNvPr id="23" name="TextBox 22"/>
+          <p:cNvSpPr txBox="1"/>
+          <p:nvPr/>
+        </p:nvSpPr>
+        <p:spPr>
+          <a:xfrm>
+            <a:off x="1143000" y="4389120"/>
+            <a:ext cx="384048" cy="384048"/>
+          </a:xfrm>
+          <a:prstGeom prst="rect">
+            <a:avLst/>
+          </a:prstGeom>
+          <a:noFill/>
+        </p:spPr>
+        <p:txBody>
+          <a:bodyPr wrap="square" anchor="ctr" lIns="0" rIns="0" tIns="0" bIns="0">
+            <a:noAutofit/>
+          </a:bodyPr>
+          <a:lstStyle/>
+          <a:p>
+            <a:pPr algn="ctr">
+              <a:spcBef>
+                <a:spcPts val="0"/>
+              </a:spcBef>
+            </a:pPr>
+            <a:r>
+              <a:rPr sz="1600" b="1">
+                <a:solidFill>
+                  <a:srgbClr val="FFFFFF"/>
+                </a:solidFill>
+                <a:latin typeface="Inter"/>
+              </a:rPr>
+              <a:t>✓</a:t>
+            </a:r>
+          </a:p>
+        </p:txBody>
+      </p:sp>
+      <p:sp>
+        <p:nvSpPr>
+          <p:cNvPr id="24" name="TextBox 23"/>
+          <p:cNvSpPr txBox="1"/>
+          <p:nvPr/>
+        </p:nvSpPr>
+        <p:spPr>
+          <a:xfrm>
+            <a:off x="1737360" y="4352544"/>
+            <a:ext cx="9372600" cy="420624"/>
+          </a:xfrm>
+          <a:prstGeom prst="rect">
+            <a:avLst/>
+          </a:prstGeom>
+          <a:noFill/>
+        </p:spPr>
+        <p:txBody>
+          <a:bodyPr wrap="square" anchor="ctr" lIns="0" rIns="0" tIns="0" bIns="0">
+            <a:noAutofit/>
+          </a:bodyPr>
+          <a:lstStyle/>
+          <a:p>
+            <a:pPr algn="l">
+              <a:spcBef>
+                <a:spcPts val="0"/>
+              </a:spcBef>
+            </a:pPr>
+            <a:r>
+              <a:rPr sz="1450" b="0">
+                <a:solidFill>
+                  <a:srgbClr val="142A33"/>
+                </a:solidFill>
+                <a:latin typeface="Inter"/>
+              </a:rPr>
+              <a:t>Zich gekend voelt en merkt dat VDT de onderneming écht begrijpt.</a:t>
+            </a:r>
+          </a:p>
+        </p:txBody>
+      </p:sp>
+      <p:sp>
+        <p:nvSpPr>
+          <p:cNvPr id="25" name="Rounded Rectangle 24"/>
+          <p:cNvSpPr/>
+          <p:nvPr/>
+        </p:nvSpPr>
+        <p:spPr>
+          <a:xfrm>
+            <a:off x="1051560" y="4855464"/>
+            <a:ext cx="10104120" cy="420624"/>
+          </a:xfrm>
+          <a:prstGeom prst="roundRect">
+            <a:avLst>
+              <a:gd name="adj" fmla="val 22000"/>
+            </a:avLst>
+          </a:prstGeom>
+          <a:solidFill>
+            <a:srgbClr val="E9F5EE"/>
+          </a:solidFill>
+          <a:ln>
+            <a:noFill/>
+          </a:ln>
+          <a:effectLst/>
+        </p:spPr>
+        <p:style>
+          <a:lnRef idx="1">
+            <a:schemeClr val="accent1"/>
+          </a:lnRef>
+          <a:fillRef idx="3">
+            <a:schemeClr val="accent1"/>
+          </a:fillRef>
+          <a:effectRef idx="2">
+            <a:schemeClr val="accent1"/>
+          </a:effectRef>
+          <a:fontRef idx="minor">
+            <a:schemeClr val="lt1"/>
+          </a:fontRef>
+        </p:style>
+        <p:txBody>
+          <a:bodyPr rtlCol="0" anchor="ctr"/>
+          <a:lstStyle/>
+          <a:p>
+            <a:pPr algn="ctr"/>
+          </a:p>
+        </p:txBody>
+      </p:sp>
+      <p:sp>
+        <p:nvSpPr>
+          <p:cNvPr id="26" name="Rounded Rectangle 25"/>
+          <p:cNvSpPr/>
+          <p:nvPr/>
+        </p:nvSpPr>
+        <p:spPr>
+          <a:xfrm>
+            <a:off x="1143000" y="4892040"/>
+            <a:ext cx="384048" cy="384048"/>
+          </a:xfrm>
+          <a:prstGeom prst="roundRect">
+            <a:avLst>
+              <a:gd name="adj" fmla="val 30000"/>
+            </a:avLst>
+          </a:prstGeom>
+          <a:solidFill>
+            <a:srgbClr val="2FA766"/>
+          </a:solidFill>
+          <a:ln>
+            <a:noFill/>
+          </a:ln>
+          <a:effectLst/>
+          <a:effectLst>
+            <a:outerShdw blurRad="90000" dist="38100" dir="5400000" rotWithShape="0">
+              <a:srgbClr val="14323B">
+                <a:alpha val="22000"/>
+              </a:srgbClr>
+            </a:outerShdw>
+          </a:effectLst>
+        </p:spPr>
+        <p:style>
+          <a:lnRef idx="1">
+            <a:schemeClr val="accent1"/>
+          </a:lnRef>
+          <a:fillRef idx="3">
+            <a:schemeClr val="accent1"/>
+          </a:fillRef>
+          <a:effectRef idx="2">
+            <a:schemeClr val="accent1"/>
+          </a:effectRef>
+          <a:fontRef idx="minor">
+            <a:schemeClr val="lt1"/>
+          </a:fontRef>
+        </p:style>
+        <p:txBody>
+          <a:bodyPr rtlCol="0" anchor="ctr"/>
+          <a:lstStyle/>
+          <a:p>
+            <a:pPr algn="ctr"/>
+          </a:p>
+        </p:txBody>
+      </p:sp>
+      <p:sp>
+        <p:nvSpPr>
+          <p:cNvPr id="27" name="TextBox 26"/>
+          <p:cNvSpPr txBox="1"/>
+          <p:nvPr/>
+        </p:nvSpPr>
+        <p:spPr>
+          <a:xfrm>
+            <a:off x="1143000" y="4892040"/>
+            <a:ext cx="384048" cy="384048"/>
+          </a:xfrm>
+          <a:prstGeom prst="rect">
+            <a:avLst/>
+          </a:prstGeom>
+          <a:noFill/>
+        </p:spPr>
+        <p:txBody>
+          <a:bodyPr wrap="square" anchor="ctr" lIns="0" rIns="0" tIns="0" bIns="0">
+            <a:noAutofit/>
+          </a:bodyPr>
+          <a:lstStyle/>
+          <a:p>
+            <a:pPr algn="ctr">
+              <a:spcBef>
+                <a:spcPts val="0"/>
+              </a:spcBef>
+            </a:pPr>
+            <a:r>
+              <a:rPr sz="1600" b="1">
+                <a:solidFill>
+                  <a:srgbClr val="FFFFFF"/>
+                </a:solidFill>
+                <a:latin typeface="Inter"/>
+              </a:rPr>
+              <a:t>✓</a:t>
+            </a:r>
+          </a:p>
+        </p:txBody>
+      </p:sp>
+      <p:sp>
+        <p:nvSpPr>
+          <p:cNvPr id="28" name="TextBox 27"/>
+          <p:cNvSpPr txBox="1"/>
+          <p:nvPr/>
+        </p:nvSpPr>
+        <p:spPr>
+          <a:xfrm>
+            <a:off x="1737360" y="4855464"/>
+            <a:ext cx="9372600" cy="420624"/>
+          </a:xfrm>
+          <a:prstGeom prst="rect">
+            <a:avLst/>
+          </a:prstGeom>
+          <a:noFill/>
+        </p:spPr>
+        <p:txBody>
+          <a:bodyPr wrap="square" anchor="ctr" lIns="0" rIns="0" tIns="0" bIns="0">
+            <a:noAutofit/>
+          </a:bodyPr>
+          <a:lstStyle/>
+          <a:p>
+            <a:pPr algn="l">
+              <a:spcBef>
+                <a:spcPts val="0"/>
+              </a:spcBef>
+            </a:pPr>
+            <a:r>
+              <a:rPr sz="1450" b="0">
+                <a:solidFill>
+                  <a:srgbClr val="142A33"/>
+                </a:solidFill>
+                <a:latin typeface="Inter"/>
+              </a:rPr>
+              <a:t>Minimaal één keer proactief is geholpen — zonder eigen verzoek.</a:t>
+            </a:r>
+          </a:p>
+        </p:txBody>
+      </p:sp>
+      <p:sp>
+        <p:nvSpPr>
+          <p:cNvPr id="29" name="Rounded Rectangle 28"/>
+          <p:cNvSpPr/>
+          <p:nvPr/>
+        </p:nvSpPr>
+        <p:spPr>
+          <a:xfrm>
+            <a:off x="640080" y="5577840"/>
+            <a:ext cx="10927080" cy="868680"/>
+          </a:xfrm>
+          <a:prstGeom prst="roundRect">
+            <a:avLst>
+              <a:gd name="adj" fmla="val 10000"/>
+            </a:avLst>
+          </a:prstGeom>
+          <a:solidFill>
+            <a:srgbClr val="2FA766"/>
+          </a:solidFill>
+          <a:ln>
+            <a:noFill/>
+          </a:ln>
+          <a:effectLst/>
+        </p:spPr>
+        <p:style>
+          <a:lnRef idx="1">
+            <a:schemeClr val="accent1"/>
+          </a:lnRef>
+          <a:fillRef idx="3">
+            <a:schemeClr val="accent1"/>
+          </a:fillRef>
+          <a:effectRef idx="2">
+            <a:schemeClr val="accent1"/>
+          </a:effectRef>
+          <a:fontRef idx="minor">
+            <a:schemeClr val="lt1"/>
+          </a:fontRef>
+        </p:style>
+        <p:txBody>
+          <a:bodyPr rtlCol="0" anchor="ctr"/>
+          <a:lstStyle/>
+          <a:p>
+            <a:pPr algn="ctr"/>
+          </a:p>
+        </p:txBody>
+      </p:sp>
+      <p:sp>
+        <p:nvSpPr>
+          <p:cNvPr id="30" name="TextBox 29"/>
+          <p:cNvSpPr txBox="1"/>
+          <p:nvPr/>
+        </p:nvSpPr>
+        <p:spPr>
+          <a:xfrm>
+            <a:off x="1005840" y="5577840"/>
+            <a:ext cx="10241280" cy="868680"/>
+          </a:xfrm>
+          <a:prstGeom prst="rect">
+            <a:avLst/>
+          </a:prstGeom>
+          <a:noFill/>
+        </p:spPr>
+        <p:txBody>
+          <a:bodyPr wrap="square" anchor="ctr" lIns="0" rIns="0" tIns="0" bIns="0">
+            <a:noAutofit/>
+          </a:bodyPr>
+          <a:lstStyle/>
+          <a:p>
+            <a:pPr algn="ctr">
+              <a:lnSpc>
+                <a:spcPct val="110000"/>
+              </a:lnSpc>
+              <a:spcBef>
+                <a:spcPts val="0"/>
+              </a:spcBef>
+            </a:pPr>
+            <a:r>
+              <a:rPr sz="1500" b="1">
+                <a:solidFill>
+                  <a:srgbClr val="FFFFFF"/>
+                </a:solidFill>
+                <a:latin typeface="Inter"/>
+              </a:rPr>
+              <a:t>Het resultaat:  </a:t>
+            </a:r>
+            <a:r>
+              <a:rPr sz="1500" b="0">
+                <a:solidFill>
+                  <a:srgbClr val="FFFFFF"/>
+                </a:solidFill>
+                <a:latin typeface="Inter"/>
+              </a:rPr>
+              <a:t>een relatie die verder gaat dan een juridisch dossier.</a:t>
+            </a:r>
+          </a:p>
+          <a:p>
+            <a:pPr algn="ctr">
+              <a:lnSpc>
+                <a:spcPct val="110000"/>
+              </a:lnSpc>
+              <a:spcBef>
+                <a:spcPts val="0"/>
+              </a:spcBef>
+            </a:pPr>
+            <a:r>
+              <a:rPr sz="1500" b="1">
+                <a:solidFill>
+                  <a:srgbClr val="EFF8F1"/>
+                </a:solidFill>
+                <a:latin typeface="Inter"/>
+              </a:rPr>
+              <a:t>Adoptie van VDT over de volle breedte.</a:t>
+            </a:r>
+          </a:p>
+        </p:txBody>
+      </p:sp>
+    </p:spTree>
+  </p:cSld>
+  <p:clrMapOvr>
+    <a:masterClrMapping/>
+  </p:clrMapOvr>
+</p:sld>
+</file>
+
+<file path=ppt/slides/slide18.xml><?xml version="1.0" encoding="utf-8"?>
 <p:sld xmlns:a="http://schemas.openxmlformats.org/drawingml/2006/main" xmlns:p="http://schemas.openxmlformats.org/presentationml/2006/main" xmlns:r="http://schemas.openxmlformats.org/officeDocument/2006/relationships">
   <p:cSld>
     <p:spTree>

</xml_diff>